<commit_message>
Credit Sean Rogers on the module materials
Adds attribution to the cover and closing slide of all three decks, the
handout footer, the practice notebook, and the README.
</commit_message>
<xml_diff>
--- a/coding_quantitative/fa26-prina-econ3291-excel_r/FA26-Prina-ECON3291-Excel-or-R-Guide.pptx
+++ b/coding_quantitative/fa26-prina-econ3291-excel_r/FA26-Prina-ECON3291-Excel-or-R-Guide.pptx
@@ -15522,7 +15522,7 @@
                   <a:srgbClr val="37474F"/>
                 </a:solidFill>
               </a:rPr>
-              <a:t>Taught by the DITI Research and Teaching Fellows</a:t>
+              <a:t>Taught by Sean Rogers  ·  DITI Research and Teaching Fellows</a:t>
             </a:r>
           </a:p>
           <a:p>
@@ -26811,7 +26811,7 @@
                   <a:srgbClr val="212121"/>
                 </a:solidFill>
               </a:rPr>
-              <a:t>Developed by DITI Research and Teaching Fellows</a:t>
+              <a:t>Developed by Sean Rogers, DITI Research and Teaching Fellows</a:t>
             </a:r>
           </a:p>
           <a:p>

</xml_diff>

<commit_message>
Use full name in attribution
</commit_message>
<xml_diff>
--- a/coding_quantitative/fa26-prina-econ3291-excel_r/FA26-Prina-ECON3291-Excel-or-R-Guide.pptx
+++ b/coding_quantitative/fa26-prina-econ3291-excel_r/FA26-Prina-ECON3291-Excel-or-R-Guide.pptx
@@ -15522,7 +15522,7 @@
                   <a:srgbClr val="37474F"/>
                 </a:solidFill>
               </a:rPr>
-              <a:t>Taught by Sean Rogers  ·  DITI Research and Teaching Fellows</a:t>
+              <a:t>Taught by Sean P. Rogers  ·  DITI Research and Teaching Fellows</a:t>
             </a:r>
           </a:p>
           <a:p>
@@ -26811,7 +26811,7 @@
                   <a:srgbClr val="212121"/>
                 </a:solidFill>
               </a:rPr>
-              <a:t>Developed by Sean Rogers, DITI Research and Teaching Fellows</a:t>
+              <a:t>Developed by Sean P. Rogers, DITI Research and Teaching Fellows</a:t>
             </a:r>
           </a:p>
           <a:p>

</xml_diff>